<commit_message>
Add disco-ball palette slide to CEO brief
New slide after "The Brand" embeds a looping GIF of the seven brand
swatches rendered as spinning mirror-tile balls, matching the disco
cut added to the web brand guidelines.
</commit_message>
<xml_diff>
--- a/YNS_CEO_Brief.pptx
+++ b/YNS_CEO_Brief.pptx
@@ -8,6 +8,7 @@
     <p:sldId id="256" r:id="rId2"/>
     <p:sldId id="257" r:id="rId3"/>
     <p:sldId id="258" r:id="rId4"/>
+    <p:sldId id="266" r:id="rId17"/>
     <p:sldId id="259" r:id="rId5"/>
     <p:sldId id="260" r:id="rId6"/>
     <p:sldId id="261" r:id="rId7"/>
@@ -2214,6 +2215,236 @@
 </p:sld>
 </file>
 
+<file path=ppt/slides/slide11.xml><?xml version="1.0" encoding="utf-8"?>
+<p:sld xmlns:a="http://schemas.openxmlformats.org/drawingml/2006/main" xmlns:p="http://schemas.openxmlformats.org/presentationml/2006/main" xmlns:r="http://schemas.openxmlformats.org/officeDocument/2006/relationships">
+  <p:cSld>
+    <p:bg>
+      <p:bgPr>
+        <a:solidFill>
+          <a:srgbClr val="0B0C10"/>
+        </a:solidFill>
+        <a:effectLst/>
+      </p:bgPr>
+    </p:bg>
+    <p:spTree>
+      <p:nvGrpSpPr>
+        <p:cNvPr id="1" name=""/>
+        <p:cNvGrpSpPr/>
+        <p:nvPr/>
+      </p:nvGrpSpPr>
+      <p:grpSpPr/>
+      <p:sp>
+        <p:nvSpPr>
+          <p:cNvPr id="2" name="Oval 1"/>
+          <p:cNvSpPr/>
+          <p:nvPr/>
+        </p:nvSpPr>
+        <p:spPr>
+          <a:xfrm>
+            <a:off x="-1400000" y="-1400000"/>
+            <a:ext cx="3400000" cy="3400000"/>
+          </a:xfrm>
+          <a:prstGeom prst="ellipse">
+            <a:avLst/>
+          </a:prstGeom>
+          <a:solidFill>
+            <a:srgbClr val="D9A13C"/>
+          </a:solidFill>
+          <a:ln>
+            <a:noFill/>
+          </a:ln>
+          <a:effectLst/>
+        </p:spPr>
+        <p:style>
+          <a:lnRef idx="1">
+            <a:schemeClr val="accent1"/>
+          </a:lnRef>
+          <a:fillRef idx="3">
+            <a:schemeClr val="accent1"/>
+          </a:fillRef>
+          <a:effectRef idx="2">
+            <a:schemeClr val="accent1"/>
+          </a:effectRef>
+          <a:fontRef idx="minor">
+            <a:schemeClr val="lt1"/>
+          </a:fontRef>
+        </p:style>
+        <p:txBody>
+          <a:bodyPr rtlCol="0" anchor="ctr"/>
+          <a:lstStyle/>
+          <a:p>
+            <a:pPr algn="ctr"/>
+          </a:p>
+        </p:txBody>
+      </p:sp>
+      <p:sp>
+        <p:nvSpPr>
+          <p:cNvPr id="3" name="TextBox 2"/>
+          <p:cNvSpPr txBox="1"/>
+          <p:nvPr/>
+        </p:nvSpPr>
+        <p:spPr>
+          <a:xfrm>
+            <a:off x="822960" y="502920"/>
+            <a:ext cx="8229600" cy="365760"/>
+          </a:xfrm>
+          <a:prstGeom prst="rect">
+            <a:avLst/>
+          </a:prstGeom>
+          <a:noFill/>
+        </p:spPr>
+        <p:txBody>
+          <a:bodyPr wrap="square">
+            <a:spAutoFit/>
+          </a:bodyPr>
+          <a:lstStyle/>
+          <a:p>
+            <a:r>
+              <a:rPr sz="1200" b="1">
+                <a:solidFill>
+                  <a:srgbClr val="16A39A"/>
+                </a:solidFill>
+                <a:latin typeface="Calibri"/>
+              </a:rPr>
+              <a:t>THE BRAND · COLOR, DISCO CUT</a:t>
+            </a:r>
+          </a:p>
+        </p:txBody>
+      </p:sp>
+      <p:sp>
+        <p:nvSpPr>
+          <p:cNvPr id="4" name="TextBox 3"/>
+          <p:cNvSpPr txBox="1"/>
+          <p:nvPr/>
+        </p:nvSpPr>
+        <p:spPr>
+          <a:xfrm>
+            <a:off x="822960" y="822960"/>
+            <a:ext cx="10424160" cy="822960"/>
+          </a:xfrm>
+          <a:prstGeom prst="rect">
+            <a:avLst/>
+          </a:prstGeom>
+          <a:noFill/>
+        </p:spPr>
+        <p:txBody>
+          <a:bodyPr wrap="square">
+            <a:spAutoFit/>
+          </a:bodyPr>
+          <a:lstStyle/>
+          <a:p>
+            <a:r>
+              <a:rPr sz="3400" b="1">
+                <a:solidFill>
+                  <a:srgbClr val="F3EFE6"/>
+                </a:solidFill>
+                <a:latin typeface="Cambria"/>
+              </a:rPr>
+              <a:t>Every hue, mirrored.</a:t>
+            </a:r>
+          </a:p>
+        </p:txBody>
+      </p:sp>
+      <p:sp>
+        <p:nvSpPr>
+          <p:cNvPr id="5" name="TextBox 4"/>
+          <p:cNvSpPr txBox="1"/>
+          <p:nvPr/>
+        </p:nvSpPr>
+        <p:spPr>
+          <a:xfrm>
+            <a:off x="822960" y="1481328"/>
+            <a:ext cx="9692640" cy="548640"/>
+          </a:xfrm>
+          <a:prstGeom prst="rect">
+            <a:avLst/>
+          </a:prstGeom>
+          <a:noFill/>
+        </p:spPr>
+        <p:txBody>
+          <a:bodyPr wrap="square">
+            <a:spAutoFit/>
+          </a:bodyPr>
+          <a:lstStyle/>
+          <a:p>
+            <a:r>
+              <a:rPr sz="1400">
+                <a:solidFill>
+                  <a:srgbClr val="C9C4B6"/>
+                </a:solidFill>
+                <a:latin typeface="Calibri"/>
+              </a:rPr>
+              <a:t>Ink, Bone, Chrome, and the four Peacock shimmers — the same palette from the brand guidelines, recast as spinning mirror balls instead of flat chips.</a:t>
+            </a:r>
+          </a:p>
+        </p:txBody>
+      </p:sp>
+      <p:pic>
+        <p:nvPicPr>
+          <p:cNvPr id="6" name="Picture 5" descr="yns_disco_swatches.gif"/>
+          <p:cNvPicPr>
+            <a:picLocks noChangeAspect="1"/>
+          </p:cNvPicPr>
+          <p:nvPr/>
+        </p:nvPicPr>
+        <p:blipFill>
+          <a:blip r:embed="rId2"/>
+          <a:stretch>
+            <a:fillRect/>
+          </a:stretch>
+        </p:blipFill>
+        <p:spPr>
+          <a:xfrm>
+            <a:off x="883767" y="3320362"/>
+            <a:ext cx="10424160" cy="1726034"/>
+          </a:xfrm>
+          <a:prstGeom prst="rect">
+            <a:avLst/>
+          </a:prstGeom>
+        </p:spPr>
+      </p:pic>
+      <p:sp>
+        <p:nvSpPr>
+          <p:cNvPr id="7" name="TextBox 6"/>
+          <p:cNvSpPr txBox="1"/>
+          <p:nvPr/>
+        </p:nvSpPr>
+        <p:spPr>
+          <a:xfrm>
+            <a:off x="822960" y="6355080"/>
+            <a:ext cx="9144000" cy="365760"/>
+          </a:xfrm>
+          <a:prstGeom prst="rect">
+            <a:avLst/>
+          </a:prstGeom>
+          <a:noFill/>
+        </p:spPr>
+        <p:txBody>
+          <a:bodyPr wrap="none">
+            <a:spAutoFit/>
+          </a:bodyPr>
+          <a:lstStyle/>
+          <a:p>
+            <a:r>
+              <a:rPr sz="1200">
+                <a:solidFill>
+                  <a:srgbClr val="C9C4B6"/>
+                </a:solidFill>
+                <a:latin typeface="Calibri"/>
+              </a:rPr>
+              <a:t>YASS &amp; SASS  ·  Brand Guidelines, Disco Cut</a:t>
+            </a:r>
+          </a:p>
+        </p:txBody>
+      </p:sp>
+    </p:spTree>
+  </p:cSld>
+  <p:clrMapOvr>
+    <a:masterClrMapping/>
+  </p:clrMapOvr>
+</p:sld>
+</file>
+
 <file path=ppt/slides/slide2.xml><?xml version="1.0" encoding="utf-8"?>
 <p:sld xmlns:a="http://schemas.openxmlformats.org/drawingml/2006/main" xmlns:r="http://schemas.openxmlformats.org/officeDocument/2006/relationships" xmlns:p="http://schemas.openxmlformats.org/presentationml/2006/main">
   <p:cSld name="Slide 2">

</xml_diff>